<commit_message>
Complete Tasks 1-10 final release package
</commit_message>
<xml_diff>
--- a/presentation/task02/Task02_Brownian_Motion.pptx
+++ b/presentation/task02/Task02_Brownian_Motion.pptx
@@ -502,12 +502,10 @@
           <a:p>
             <a:r>
               <a:rPr lang="en-US" dirty="0"/>
-              <a:t>FINAL SCRIPT (approximately 17–18 seconds)
+              <a:t>FINAL SCRIPT
 Task 2 models one thousand small particles colliding with a larger particle initially at rest, producing an irregular path. Across sixty-four runs, displacement was unbiased and mean-squared displacement was linear: R squared 0.983, with a diffusion coefficient of 2.25 times ten to the minus three.
-CUES
-0–6 s: tracer animation and trail.
-6–12 s: endpoint cloud and unbiased result.
-12–18 s: linear fit and diffusion coefficient.</a:t>
+MASTER-DECK CUE
+Follow model, validation evidence, then result.</a:t>
             </a:r>
             <a:endParaRPr lang="en-US" dirty="0"/>
           </a:p>
@@ -862,7 +860,7 @@
     <p:bg>
       <p:bgPr>
         <a:solidFill>
-          <a:srgbClr val="F7FAFC"/>
+          <a:srgbClr val="FFFFFF"/>
         </a:solidFill>
       </p:bgPr>
     </p:bg>
@@ -880,141 +878,9 @@
           <a:chExt cx="0" cy="0"/>
         </a:xfrm>
       </p:grpSpPr>
-      <p:sp>
-        <p:nvSpPr>
-          <p:cNvPr id="2" name="Text 0"/>
-          <p:cNvSpPr/>
-          <p:nvPr/>
-        </p:nvSpPr>
-        <p:spPr>
-          <a:xfrm>
-            <a:off x="475488" y="201168"/>
-            <a:ext cx="11247120" cy="438912"/>
-          </a:xfrm>
-          <a:prstGeom prst="rect">
-            <a:avLst/>
-          </a:prstGeom>
-          <a:noFill/>
-          <a:ln/>
-        </p:spPr>
-        <p:txBody>
-          <a:bodyPr wrap="square" lIns="0" tIns="0" rIns="0" bIns="0" rtlCol="0" anchor="ctr">
-            <a:normAutofit/>
-          </a:bodyPr>
-          <a:lstStyle/>
-          <a:p>
-            <a:pPr indent="0" marL="0">
-              <a:buNone/>
-            </a:pPr>
-            <a:r>
-              <a:rPr lang="en-US" sz="2800" b="1" dirty="0">
-                <a:solidFill>
-                  <a:srgbClr val="243447"/>
-                </a:solidFill>
-                <a:latin typeface="Arial" pitchFamily="34" charset="0"/>
-                <a:ea typeface="Arial" pitchFamily="34" charset="-122"/>
-                <a:cs typeface="Arial" pitchFamily="34" charset="-120"/>
-              </a:rPr>
-              <a:t>Task 2 — Collision-Driven Brownian Motion</a:t>
-            </a:r>
-            <a:endParaRPr lang="en-US" sz="2800" dirty="0"/>
-          </a:p>
-        </p:txBody>
-      </p:sp>
-      <p:sp>
-        <p:nvSpPr>
-          <p:cNvPr id="3" name="Text 1"/>
-          <p:cNvSpPr/>
-          <p:nvPr/>
-        </p:nvSpPr>
-        <p:spPr>
-          <a:xfrm>
-            <a:off x="493776" y="694944"/>
-            <a:ext cx="11064240" cy="256032"/>
-          </a:xfrm>
-          <a:prstGeom prst="rect">
-            <a:avLst/>
-          </a:prstGeom>
-          <a:noFill/>
-          <a:ln/>
-        </p:spPr>
-        <p:txBody>
-          <a:bodyPr wrap="square" lIns="0" tIns="0" rIns="0" bIns="0" rtlCol="0" anchor="ctr">
-            <a:normAutofit/>
-          </a:bodyPr>
-          <a:lstStyle/>
-          <a:p>
-            <a:pPr indent="0" marL="0">
-              <a:buNone/>
-            </a:pPr>
-            <a:r>
-              <a:rPr lang="en-US" sz="1650" b="1" dirty="0">
-                <a:solidFill>
-                  <a:srgbClr val="0072B2"/>
-                </a:solidFill>
-                <a:latin typeface="Arial" pitchFamily="34" charset="0"/>
-                <a:ea typeface="Arial" pitchFamily="34" charset="-122"/>
-                <a:cs typeface="Arial" pitchFamily="34" charset="-120"/>
-              </a:rPr>
-              <a:t>Random molecular impacts produce unbiased diffusive tracer motion.</a:t>
-            </a:r>
-            <a:endParaRPr lang="en-US" sz="1650" dirty="0"/>
-          </a:p>
-        </p:txBody>
-      </p:sp>
-      <p:sp>
-        <p:nvSpPr>
-          <p:cNvPr id="4" name="Shape 2"/>
-          <p:cNvSpPr/>
-          <p:nvPr/>
-        </p:nvSpPr>
-        <p:spPr>
-          <a:xfrm>
-            <a:off x="475488" y="1024128"/>
-            <a:ext cx="11247120" cy="0"/>
-          </a:xfrm>
-          <a:prstGeom prst="line">
-            <a:avLst/>
-          </a:prstGeom>
-          <a:noFill/>
-          <a:ln w="28575">
-            <a:solidFill>
-              <a:srgbClr val="0072B2"/>
-            </a:solidFill>
-            <a:prstDash val="solid"/>
-          </a:ln>
-        </p:spPr>
-      </p:sp>
-      <p:sp>
-        <p:nvSpPr>
-          <p:cNvPr id="5" name="Shape 3"/>
-          <p:cNvSpPr/>
-          <p:nvPr/>
-        </p:nvSpPr>
-        <p:spPr>
-          <a:xfrm>
-            <a:off x="420624" y="1197864"/>
-            <a:ext cx="4005072" cy="5202936"/>
-          </a:xfrm>
-          <a:prstGeom prst="roundRect">
-            <a:avLst>
-              <a:gd name="adj" fmla="val 1142"/>
-            </a:avLst>
-          </a:prstGeom>
-          <a:solidFill>
-            <a:srgbClr val="FFFFFF"/>
-          </a:solidFill>
-          <a:ln w="12700">
-            <a:solidFill>
-              <a:srgbClr val="DCE3E8"/>
-            </a:solidFill>
-            <a:prstDash val="solid"/>
-          </a:ln>
-        </p:spPr>
-      </p:sp>
       <p:pic>
         <p:nvPicPr>
-          <p:cNvPr id="6" name="Image 0" descr="One thousand blue small particles collide with a large translucent yellow tracer while an orange irregular path accumulates.">    </p:cNvPr>
+          <p:cNvPr id="2" name="Image 0" descr="Task 2 summary. A large tracer moves through one thousand small particles. Sixty-four trajectories give a linear intermediate mean-squared displacement with R squared 0.983 and diffusion coefficient 2.25 times ten to the minus three square nanometres per picosecond. The endpoint cloud and confidence intervals show no drift.">    </p:cNvPr>
           <p:cNvPicPr>
             <a:picLocks noChangeAspect="1"/>
           </p:cNvPicPr>
@@ -1028,415 +894,14 @@
         </p:blipFill>
         <p:spPr>
           <a:xfrm>
-            <a:off x="585216" y="1362456"/>
-            <a:ext cx="3675888" cy="3675888"/>
+            <a:off x="109728" y="73152"/>
+            <a:ext cx="11969496" cy="6729984"/>
           </a:xfrm>
           <a:prstGeom prst="rect">
             <a:avLst/>
           </a:prstGeom>
         </p:spPr>
       </p:pic>
-      <p:sp>
-        <p:nvSpPr>
-          <p:cNvPr id="7" name="Text 4"/>
-          <p:cNvSpPr/>
-          <p:nvPr/>
-        </p:nvSpPr>
-        <p:spPr>
-          <a:xfrm>
-            <a:off x="640080" y="5248656"/>
-            <a:ext cx="3566160" cy="283464"/>
-          </a:xfrm>
-          <a:prstGeom prst="rect">
-            <a:avLst/>
-          </a:prstGeom>
-          <a:noFill/>
-          <a:ln/>
-        </p:spPr>
-        <p:txBody>
-          <a:bodyPr wrap="square" lIns="0" tIns="0" rIns="0" bIns="0" rtlCol="0" anchor="ctr"/>
-          <a:lstStyle/>
-          <a:p>
-            <a:pPr algn="ctr" indent="0" marL="0">
-              <a:buNone/>
-            </a:pPr>
-            <a:r>
-              <a:rPr lang="en-US" sz="1700" b="1" dirty="0">
-                <a:solidFill>
-                  <a:srgbClr val="243447"/>
-                </a:solidFill>
-                <a:latin typeface="Arial" pitchFamily="34" charset="0"/>
-                <a:ea typeface="Arial" pitchFamily="34" charset="-122"/>
-                <a:cs typeface="Arial" pitchFamily="34" charset="-120"/>
-              </a:rPr>
-              <a:t>Reference simulation</a:t>
-            </a:r>
-            <a:endParaRPr lang="en-US" sz="1700" dirty="0"/>
-          </a:p>
-        </p:txBody>
-      </p:sp>
-      <p:sp>
-        <p:nvSpPr>
-          <p:cNvPr id="8" name="Text 5"/>
-          <p:cNvSpPr/>
-          <p:nvPr/>
-        </p:nvSpPr>
-        <p:spPr>
-          <a:xfrm>
-            <a:off x="585216" y="5605272"/>
-            <a:ext cx="3675888" cy="475488"/>
-          </a:xfrm>
-          <a:prstGeom prst="rect">
-            <a:avLst/>
-          </a:prstGeom>
-          <a:noFill/>
-          <a:ln/>
-        </p:spPr>
-        <p:txBody>
-          <a:bodyPr wrap="square" lIns="0" tIns="0" rIns="0" bIns="0" rtlCol="0" anchor="ctr">
-            <a:normAutofit/>
-          </a:bodyPr>
-          <a:lstStyle/>
-          <a:p>
-            <a:pPr algn="ctr" indent="0" marL="0">
-              <a:buNone/>
-            </a:pPr>
-            <a:r>
-              <a:rPr lang="en-US" sz="1350" dirty="0">
-                <a:solidFill>
-                  <a:srgbClr val="6B7B8C"/>
-                </a:solidFill>
-                <a:latin typeface="Arial" pitchFamily="34" charset="0"/>
-                <a:ea typeface="Arial" pitchFamily="34" charset="-122"/>
-                <a:cs typeface="Arial" pitchFamily="34" charset="-120"/>
-              </a:rPr>
-              <a:t>N = 1,000  •  200 ps  •  3,721 collision impulses</a:t>
-            </a:r>
-            <a:endParaRPr lang="en-US" sz="1350" dirty="0"/>
-          </a:p>
-        </p:txBody>
-      </p:sp>
-      <p:sp>
-        <p:nvSpPr>
-          <p:cNvPr id="9" name="Shape 6"/>
-          <p:cNvSpPr/>
-          <p:nvPr/>
-        </p:nvSpPr>
-        <p:spPr>
-          <a:xfrm>
-            <a:off x="4608576" y="1197864"/>
-            <a:ext cx="7168896" cy="3273552"/>
-          </a:xfrm>
-          <a:prstGeom prst="roundRect">
-            <a:avLst>
-              <a:gd name="adj" fmla="val 1397"/>
-            </a:avLst>
-          </a:prstGeom>
-          <a:solidFill>
-            <a:srgbClr val="FFFFFF"/>
-          </a:solidFill>
-          <a:ln w="12700">
-            <a:solidFill>
-              <a:srgbClr val="DCE3E8"/>
-            </a:solidFill>
-            <a:prstDash val="solid"/>
-          </a:ln>
-        </p:spPr>
-      </p:sp>
-      <p:pic>
-        <p:nvPicPr>
-          <p:cNvPr id="10" name="Image 1" descr="A 64-run mean-squared-displacement curve with a linear fit and confidence band, beside an approximately circular endpoint cloud.">    </p:cNvPr>
-          <p:cNvPicPr>
-            <a:picLocks noChangeAspect="1"/>
-          </p:cNvPicPr>
-          <p:nvPr/>
-        </p:nvPicPr>
-        <p:blipFill>
-          <a:blip r:embed="rId2"/>
-          <a:stretch>
-            <a:fillRect/>
-          </a:stretch>
-        </p:blipFill>
-        <p:spPr>
-          <a:xfrm>
-            <a:off x="4773168" y="1380744"/>
-            <a:ext cx="6839712" cy="2953512"/>
-          </a:xfrm>
-          <a:prstGeom prst="rect">
-            <a:avLst/>
-          </a:prstGeom>
-        </p:spPr>
-      </p:pic>
-      <p:sp>
-        <p:nvSpPr>
-          <p:cNvPr id="11" name="Shape 7"/>
-          <p:cNvSpPr/>
-          <p:nvPr/>
-        </p:nvSpPr>
-        <p:spPr>
-          <a:xfrm>
-            <a:off x="4608576" y="4645152"/>
-            <a:ext cx="7168896" cy="1755648"/>
-          </a:xfrm>
-          <a:prstGeom prst="roundRect">
-            <a:avLst>
-              <a:gd name="adj" fmla="val 2604"/>
-            </a:avLst>
-          </a:prstGeom>
-          <a:solidFill>
-            <a:srgbClr val="FFFFFF"/>
-          </a:solidFill>
-          <a:ln w="12700">
-            <a:solidFill>
-              <a:srgbClr val="DCE3E8"/>
-            </a:solidFill>
-            <a:prstDash val="solid"/>
-          </a:ln>
-        </p:spPr>
-      </p:sp>
-      <p:sp>
-        <p:nvSpPr>
-          <p:cNvPr id="12" name="Shape 8"/>
-          <p:cNvSpPr/>
-          <p:nvPr/>
-        </p:nvSpPr>
-        <p:spPr>
-          <a:xfrm>
-            <a:off x="4855464" y="4910328"/>
-            <a:ext cx="128016" cy="128016"/>
-          </a:xfrm>
-          <a:prstGeom prst="ellipse">
-            <a:avLst/>
-          </a:prstGeom>
-          <a:solidFill>
-            <a:srgbClr val="009E73"/>
-          </a:solidFill>
-          <a:ln w="12700">
-            <a:solidFill>
-              <a:srgbClr val="009E73">
-                <a:alpha val="0"/>
-              </a:srgbClr>
-            </a:solidFill>
-            <a:prstDash val="solid"/>
-          </a:ln>
-        </p:spPr>
-      </p:sp>
-      <p:sp>
-        <p:nvSpPr>
-          <p:cNvPr id="13" name="Text 9"/>
-          <p:cNvSpPr/>
-          <p:nvPr/>
-        </p:nvSpPr>
-        <p:spPr>
-          <a:xfrm>
-            <a:off x="5102352" y="4837176"/>
-            <a:ext cx="6419088" cy="310896"/>
-          </a:xfrm>
-          <a:prstGeom prst="rect">
-            <a:avLst/>
-          </a:prstGeom>
-          <a:noFill/>
-          <a:ln/>
-        </p:spPr>
-        <p:txBody>
-          <a:bodyPr wrap="square" lIns="0" tIns="0" rIns="0" bIns="0" rtlCol="0" anchor="ctr">
-            <a:normAutofit/>
-          </a:bodyPr>
-          <a:lstStyle/>
-          <a:p>
-            <a:pPr indent="0" marL="0">
-              <a:buNone/>
-            </a:pPr>
-            <a:r>
-              <a:rPr lang="en-US" sz="1750" dirty="0">
-                <a:solidFill>
-                  <a:srgbClr val="243447"/>
-                </a:solidFill>
-                <a:latin typeface="Arial" pitchFamily="34" charset="0"/>
-                <a:ea typeface="Arial" pitchFamily="34" charset="-122"/>
-                <a:cs typeface="Arial" pitchFamily="34" charset="-120"/>
-              </a:rPr>
-              <a:t>64-run ensemble: ⟨Δx⟩ and ⟨Δy⟩ 95% CIs include 0</a:t>
-            </a:r>
-            <a:endParaRPr lang="en-US" sz="1750" dirty="0"/>
-          </a:p>
-        </p:txBody>
-      </p:sp>
-      <p:sp>
-        <p:nvSpPr>
-          <p:cNvPr id="14" name="Shape 10"/>
-          <p:cNvSpPr/>
-          <p:nvPr/>
-        </p:nvSpPr>
-        <p:spPr>
-          <a:xfrm>
-            <a:off x="4855464" y="5385816"/>
-            <a:ext cx="128016" cy="128016"/>
-          </a:xfrm>
-          <a:prstGeom prst="ellipse">
-            <a:avLst/>
-          </a:prstGeom>
-          <a:solidFill>
-            <a:srgbClr val="D55E00"/>
-          </a:solidFill>
-          <a:ln w="12700">
-            <a:solidFill>
-              <a:srgbClr val="D55E00">
-                <a:alpha val="0"/>
-              </a:srgbClr>
-            </a:solidFill>
-            <a:prstDash val="solid"/>
-          </a:ln>
-        </p:spPr>
-      </p:sp>
-      <p:sp>
-        <p:nvSpPr>
-          <p:cNvPr id="15" name="Text 11"/>
-          <p:cNvSpPr/>
-          <p:nvPr/>
-        </p:nvSpPr>
-        <p:spPr>
-          <a:xfrm>
-            <a:off x="5102352" y="5312664"/>
-            <a:ext cx="6419088" cy="310896"/>
-          </a:xfrm>
-          <a:prstGeom prst="rect">
-            <a:avLst/>
-          </a:prstGeom>
-          <a:noFill/>
-          <a:ln/>
-        </p:spPr>
-        <p:txBody>
-          <a:bodyPr wrap="square" lIns="0" tIns="0" rIns="0" bIns="0" rtlCol="0" anchor="ctr">
-            <a:normAutofit/>
-          </a:bodyPr>
-          <a:lstStyle/>
-          <a:p>
-            <a:pPr indent="0" marL="0">
-              <a:buNone/>
-            </a:pPr>
-            <a:r>
-              <a:rPr lang="en-US" sz="1750" dirty="0">
-                <a:solidFill>
-                  <a:srgbClr val="243447"/>
-                </a:solidFill>
-                <a:latin typeface="Arial" pitchFamily="34" charset="0"/>
-                <a:ea typeface="Arial" pitchFamily="34" charset="-122"/>
-                <a:cs typeface="Arial" pitchFamily="34" charset="-120"/>
-              </a:rPr>
-              <a:t>MSD ∝ t: R² = 0.983; D = 2.25 × 10⁻³ nm² ps⁻¹</a:t>
-            </a:r>
-            <a:endParaRPr lang="en-US" sz="1750" dirty="0"/>
-          </a:p>
-        </p:txBody>
-      </p:sp>
-      <p:sp>
-        <p:nvSpPr>
-          <p:cNvPr id="16" name="Shape 12"/>
-          <p:cNvSpPr/>
-          <p:nvPr/>
-        </p:nvSpPr>
-        <p:spPr>
-          <a:xfrm>
-            <a:off x="4855464" y="5861304"/>
-            <a:ext cx="128016" cy="128016"/>
-          </a:xfrm>
-          <a:prstGeom prst="ellipse">
-            <a:avLst/>
-          </a:prstGeom>
-          <a:solidFill>
-            <a:srgbClr val="0072B2"/>
-          </a:solidFill>
-          <a:ln w="12700">
-            <a:solidFill>
-              <a:srgbClr val="0072B2">
-                <a:alpha val="0"/>
-              </a:srgbClr>
-            </a:solidFill>
-            <a:prstDash val="solid"/>
-          </a:ln>
-        </p:spPr>
-      </p:sp>
-      <p:sp>
-        <p:nvSpPr>
-          <p:cNvPr id="17" name="Text 13"/>
-          <p:cNvSpPr/>
-          <p:nvPr/>
-        </p:nvSpPr>
-        <p:spPr>
-          <a:xfrm>
-            <a:off x="5102352" y="5788152"/>
-            <a:ext cx="6419088" cy="310896"/>
-          </a:xfrm>
-          <a:prstGeom prst="rect">
-            <a:avLst/>
-          </a:prstGeom>
-          <a:noFill/>
-          <a:ln/>
-        </p:spPr>
-        <p:txBody>
-          <a:bodyPr wrap="square" lIns="0" tIns="0" rIns="0" bIns="0" rtlCol="0" anchor="ctr">
-            <a:normAutofit/>
-          </a:bodyPr>
-          <a:lstStyle/>
-          <a:p>
-            <a:pPr indent="0" marL="0">
-              <a:buNone/>
-            </a:pPr>
-            <a:r>
-              <a:rPr lang="en-US" sz="1750" dirty="0">
-                <a:solidFill>
-                  <a:srgbClr val="243447"/>
-                </a:solidFill>
-                <a:latin typeface="Arial" pitchFamily="34" charset="0"/>
-                <a:ea typeface="Arial" pitchFamily="34" charset="-122"/>
-                <a:cs typeface="Arial" pitchFamily="34" charset="-120"/>
-              </a:rPr>
-              <a:t>Time-step halving: ΔD = 5.7%; all 224 runs numerically valid</a:t>
-            </a:r>
-            <a:endParaRPr lang="en-US" sz="1750" dirty="0"/>
-          </a:p>
-        </p:txBody>
-      </p:sp>
-      <p:sp>
-        <p:nvSpPr>
-          <p:cNvPr id="18" name="Text 14"/>
-          <p:cNvSpPr/>
-          <p:nvPr/>
-        </p:nvSpPr>
-        <p:spPr>
-          <a:xfrm>
-            <a:off x="8778240" y="6537960"/>
-            <a:ext cx="2926080" cy="146304"/>
-          </a:xfrm>
-          <a:prstGeom prst="rect">
-            <a:avLst/>
-          </a:prstGeom>
-          <a:noFill/>
-          <a:ln/>
-        </p:spPr>
-        <p:txBody>
-          <a:bodyPr wrap="square" lIns="0" tIns="0" rIns="0" bIns="0" rtlCol="0" anchor="ctr"/>
-          <a:lstStyle/>
-          <a:p>
-            <a:pPr algn="r" indent="0" marL="0">
-              <a:buNone/>
-            </a:pPr>
-            <a:r>
-              <a:rPr lang="en-US" sz="850" dirty="0">
-                <a:solidFill>
-                  <a:srgbClr val="6B7B8C"/>
-                </a:solidFill>
-                <a:latin typeface="Arial" pitchFamily="34" charset="0"/>
-                <a:ea typeface="Arial" pitchFamily="34" charset="-122"/>
-                <a:cs typeface="Arial" pitchFamily="34" charset="-120"/>
-              </a:rPr>
-              <a:t>BPhO Computational Challenge 2026</a:t>
-            </a:r>
-            <a:endParaRPr lang="en-US" sz="850" dirty="0"/>
-          </a:p>
-        </p:txBody>
-      </p:sp>
     </p:spTree>
   </p:cSld>
   <p:clrMapOvr>
@@ -1488,7 +953,7 @@
     </a:clrScheme>
     <a:fontScheme name="Office">
       <a:majorFont>
-        <a:latin typeface="Arial"/>
+        <a:latin typeface="Times New Roman"/>
         <a:ea typeface=""/>
         <a:cs typeface=""/>
         <a:font script="Jpan" typeface="游ゴシック Light"/>
@@ -1521,7 +986,7 @@
         <a:font script="Viet" typeface="Times New Roman"/>
         <a:font script="Uigh" typeface="Microsoft Uighur"/>
         <a:font script="Geor" typeface="Sylfaen"/>
-        <a:font script="Armn" typeface="Arial"/>
+        <a:font script="Armn" typeface="Times New Roman"/>
         <a:font script="Bugi" typeface="Leelawadee UI"/>
         <a:font script="Bopo" typeface="Microsoft JhengHei"/>
         <a:font script="Java" typeface="Javanese Text"/>
@@ -1540,15 +1005,15 @@
         <a:font script="Tfng" typeface="Ebrima"/>
       </a:majorFont>
       <a:minorFont>
-        <a:latin typeface="Arial"/>
+        <a:latin typeface="Times New Roman"/>
         <a:ea typeface=""/>
         <a:cs typeface=""/>
         <a:font script="Jpan" typeface="游ゴシック"/>
         <a:font script="Hang" typeface="맑은 고딕"/>
         <a:font script="Hans" typeface="等线"/>
         <a:font script="Hant" typeface="新細明體"/>
-        <a:font script="Arab" typeface="Arial"/>
-        <a:font script="Hebr" typeface="Arial"/>
+        <a:font script="Arab" typeface="Times New Roman"/>
+        <a:font script="Hebr" typeface="Times New Roman"/>
         <a:font script="Thai" typeface="Cordia New"/>
         <a:font script="Ethi" typeface="Nyala"/>
         <a:font script="Beng" typeface="Vrinda"/>
@@ -1570,10 +1035,10 @@
         <a:font script="Laoo" typeface="DokChampa"/>
         <a:font script="Sinh" typeface="Iskoola Pota"/>
         <a:font script="Mong" typeface="Mongolian Baiti"/>
-        <a:font script="Viet" typeface="Arial"/>
+        <a:font script="Viet" typeface="Times New Roman"/>
         <a:font script="Uigh" typeface="Microsoft Uighur"/>
         <a:font script="Geor" typeface="Sylfaen"/>
-        <a:font script="Armn" typeface="Arial"/>
+        <a:font script="Armn" typeface="Times New Roman"/>
         <a:font script="Bugi" typeface="Leelawadee UI"/>
         <a:font script="Bopo" typeface="Microsoft JhengHei"/>
         <a:font script="Java" typeface="Javanese Text"/>

</xml_diff>